<commit_message>
docs(goai): update submission materials with live deployment fix
Streamlit Cloud had its Python version pinned to 3.13 (project targets
3.10), which silently broke dependency resolution and crashed every
page. Fixed via the dashboard and reverified the full app, including
the new business profile view, now loads correctly in production.

A real end-to-end upload test against the live app surfaced a separate,
genuine issue: the configured API key is rejected by the provider
(403), matching an account-ban issue already on record for a sibling
project. Update all submission docs and the generated PPT to reflect
this accurately instead of the prior "local only" framing.
</commit_message>
<xml_diff>
--- a/hackathon/goai-2026-submission/WeFinance-GOAI2026-初赛PPT-v1.pptx
+++ b/hackathon/goai-2026-submission/WeFinance-GOAI2026-初赛PPT-v1.pptx
@@ -3626,7 +3626,7 @@
                   <a:srgbClr val="1E293B"/>
                 </a:solidFill>
               </a:rPr>
-              <a:t>实测中顺带发现并修复两个真实工程缺陷（st.dataframe 参数兼容崩溃、pyarrow/numpy ABI 不兼容导致的原生崩溃）；GOAI 参赛材料</a:t>
+              <a:t>实测中顺带发现并修复三个真实工程缺陷（st.dataframe 参数兼容崩溃、pyarrow/numpy ABI 不兼容导致的原生崩溃、线上 Python 版本配置错误）；GOAI 参赛材料</a:t>
             </a:r>
           </a:p>
         </p:txBody>
@@ -4901,7 +4901,7 @@
                   <a:srgbClr val="1E293B"/>
                 </a:solidFill>
               </a:rPr>
-              <a:t>线上实测（2026-08-08，未通过，如实标注）：Streamlit Cloud 因 ModuleNotFoundError 无法加载，属平台侧环境问题，需登录 Dashboard 重新部署</a:t>
+              <a:t>线上实测（2026-08-09）：Streamlit Cloud Python 版本配置错误（3.13）导致全部页面无法加载，已修复为 3.10 并重新验证，页面恢复正常</a:t>
             </a:r>
           </a:p>
           <a:p>
@@ -4916,7 +4916,7 @@
                   <a:srgbClr val="1E293B"/>
                 </a:solidFill>
               </a:rPr>
-              <a:t>实测中顺带发现并修复三个真实工程缺陷：理财建议合规风险、st.dataframe 参数兼容崩溃、pyarrow/numpy ABI 不兼容崩溃</a:t>
+              <a:t>线上真实上传账单触发 OCR 调用，因 Secrets 中 API key 被服务商拒绝（403）未跑通，非代码问题，失败路径按设计优雅降级</a:t>
             </a:r>
           </a:p>
         </p:txBody>

</xml_diff>

<commit_message>
fix(goai): correct overclaims and close compliance gaps in submission materials
Audit-driven pass across the GOAI 2026 submission package: adds a real
MIT LICENSE file to back the license claim already public in README,
fixes 3 code-quality bugs in the business profile page (dead-code
merchant fallback, unformatted amount, generic anomaly empty-state),
and corrects several overstated claims across 项目一页纸.md,
PPT-内容稿.md, tools/build_goai_ppt.py, and 官方要求对照清单.md:
safe_call/timeout coverage is not uniform across all LLM calls (Chat
has no hard timeout, only retry+backoff), the dev timeline overstated
by two months, the engineering-bug list was missing the just-fixed
HTML rendering defect, and generate_detailed_report's real timeout is
60s not 30s. Also adds missing manual-compliance coverage for 8.4
(memory/context, data deletion), 8.5 (external API permission scope),
and 10.2 (AI+金融 track-specific review criteria).
</commit_message>
<xml_diff>
--- a/hackathon/goai-2026-submission/WeFinance-GOAI2026-初赛PPT-v1.pptx
+++ b/hackathon/goai-2026-submission/WeFinance-GOAI2026-初赛PPT-v1.pptx
@@ -3391,7 +3391,7 @@
                   <a:srgbClr val="1E293B"/>
                 </a:solidFill>
               </a:rPr>
-              <a:t>近期：修复线上 Streamlit Cloud 部署问题，稳定 Demo 可用性</a:t>
+              <a:t>近期：线上部署问题已修复（Python 3.13→3.10），待用户更新 API key 后复测 OCR 全链路</a:t>
             </a:r>
           </a:p>
           <a:p>
@@ -3596,7 +3596,7 @@
                   <a:srgbClr val="1E293B"/>
                 </a:solidFill>
               </a:rPr>
-              <a:t>原有基础：2025 年 11 月至 2026 年 1 月开发的完整产品，票据识别、消费分析、AI 顾问、投资建议四大核心链路已上线运行，GitHub 128 星</a:t>
+              <a:t>原有基础：2025 年 11 月开发的完整产品，票据识别、消费分析、AI 顾问、投资建议四大核心链路已上线运行，GitHub 128 星</a:t>
             </a:r>
           </a:p>
           <a:p>
@@ -3626,7 +3626,7 @@
                   <a:srgbClr val="1E293B"/>
                 </a:solidFill>
               </a:rPr>
-              <a:t>实测中顺带发现并修复三个真实工程缺陷（st.dataframe 参数兼容崩溃、pyarrow/numpy ABI 不兼容导致的原生崩溃、线上 Python 版本配置错误）；GOAI 参赛材料</a:t>
+              <a:t>实测中顺带发现并修复四个真实工程缺陷（st.dataframe 参数兼容崩溃、pyarrow/numpy ABI 不兼容导致的原生崩溃、线上 Python 版本配置错误、财务健康卡片 HTML 渲染为纯文本）；GOAI 参赛材料</a:t>
             </a:r>
           </a:p>
         </p:txBody>
@@ -4461,7 +4461,7 @@
                   <a:srgbClr val="1E293B"/>
                 </a:solidFill>
               </a:rPr>
-              <a:t>结果交付：结构化交易记录、异常预警卡片、可解释推理链（理财建议附带 rationale_steps）</a:t>
+              <a:t>结果交付：结构化交易记录、异常预警卡片、经营画像聚合视图（交易对手集中度/收支趋势）、可解释推理链（理财建议附带 rationale_steps）</a:t>
             </a:r>
           </a:p>
           <a:p>
@@ -4696,7 +4696,7 @@
                   <a:srgbClr val="1E293B"/>
                 </a:solidFill>
               </a:rPr>
-              <a:t>全部服务层通过 @safe_call 装饰器提供超时保护和优雅降级</a:t>
+              <a:t>多数服务层通过 @safe_call 装饰器提供超时保护和优雅降级；Chat 走独立的重试+退避机制</a:t>
             </a:r>
           </a:p>
           <a:p>

</xml_diff>

<commit_message>
docs(goai): update Demo slide with successful live OCR result
Live testing on 2026-08-11 initially hit a 403 that looked like an API
key problem; root cause was SiliconFlow deprecating the pinned vision
model, not the key. After switching to an active model the live demo
now recognizes 4/4 sample transactions end to end. Replace the old
403-failure narrative on the Demo slide with this result.
</commit_message>
<xml_diff>
--- a/hackathon/goai-2026-submission/WeFinance-GOAI2026-初赛PPT-v1.pptx
+++ b/hackathon/goai-2026-submission/WeFinance-GOAI2026-初赛PPT-v1.pptx
@@ -4901,7 +4901,7 @@
                   <a:srgbClr val="1E293B"/>
                 </a:solidFill>
               </a:rPr>
-              <a:t>线上实测（2026-08-09）：Streamlit Cloud Python 版本配置错误（3.13）导致全部页面无法加载，已修复为 3.10 并重新验证，页面恢复正常</a:t>
+              <a:t>线上实测（2026-08-11，通过）：真实上传样例账单触发线上 OCR 调用，4/4 笔交易全部正确识别（商户/日期/金额/分类）</a:t>
             </a:r>
           </a:p>
           <a:p>
@@ -4916,7 +4916,7 @@
                   <a:srgbClr val="1E293B"/>
                 </a:solidFill>
               </a:rPr>
-              <a:t>线上真实上传账单触发 OCR 调用，因 Secrets 中 API key 被服务商拒绝（403）未跑通，非代码问题，失败路径按设计优雅降级</a:t>
+              <a:t>过程中定位到服务商侧模型下线（Qwen2-VL-72B-Instruct 已 deprecated）导致的持续 403，切换至当前活跃模型后修复，非代码缺陷</a:t>
             </a:r>
           </a:p>
         </p:txBody>

</xml_diff>